<commit_message>
Add prebuilt RV64 P toolchain and QEMU
</commit_message>
<xml_diff>
--- a/docs/RVP-Image-SAD.pptx
+++ b/docs/RVP-Image-SAD.pptx
@@ -342,7 +342,7 @@
             <a:pPr indent="0" algn="r">
               <a:buNone/>
             </a:pPr>
-            <a:fld id="{2326F13B-970F-4F3C-970B-7FDB71920516}" type="slidenum">
+            <a:fld id="{B2E03B9A-FDBB-4BBB-B97A-693500AE815E}" type="slidenum">
               <a:rPr b="0" lang="en-US" sz="1400" spc="-1" strike="noStrike">
                 <a:solidFill>
                   <a:srgbClr val="000000"/>
@@ -861,7 +861,7 @@
         <p:spPr>
           <a:xfrm>
             <a:off x="756000" y="5078520"/>
-            <a:ext cx="6048000" cy="5950080"/>
+            <a:ext cx="6048000" cy="6233400"/>
           </a:xfrm>
           <a:prstGeom prst="rect">
             <a:avLst/>
@@ -886,7 +886,7 @@
                 </a:solidFill>
                 <a:latin typeface="Arial"/>
               </a:rPr>
-              <a:t>The repository includes the scalar and intrinsic C kernels, build and run scripts, a notebook, and independent image validation. Python only drives the tools and provides an independent oracle; the image-processing kernel is C. Follow docs/BUILD.md to build the P-enabled tools, then run bash scripts/present.sh. Run bash scripts/acceptance.sh for O2, O3 and Os checks and negative controls. Each optimization configuration passes 82,576 C checks and 289 independently recomputed image costs. Negative controls catch P-disabled execution and a modified input pixel. Tested versions: GCC 16.1.0, Binutils 2.47, glibc 2.43 and QEMU 11.1.50 with local P support, on x86_64 Ubuntu 24.04.2 / glibc 2.39 under WSL2. This is validation of the provided static RV64 C example, not certification of the full P ISA or other toolchain configurations. P 0.6 is a developed draft, not ratified. Code and tutorial license: MIT. See VERSION.json, VALIDATION.md and licenses/NOTICE for details.</a:t>
+              <a:t>The repository includes the scalar and intrinsic C kernels, build and run scripts, a notebook, and independent image validation. Python only drives the tools and provides an independent oracle; the image-processing kernel is C. Prebuilt P-enabled tools are included for x86_64 Linux. Run bash scripts/present.sh; rebuilding the tools is optional and documented in docs/BUILD.md. Run bash scripts/acceptance.sh for O2, O3 and Os checks and negative controls. Each optimization configuration passes 82,576 C checks and 289 independently recomputed image costs. Negative controls catch P-disabled execution and a modified input pixel. Tested versions: GCC 16.1.0, Binutils 2.47, glibc 2.43 and QEMU 11.1.50 with local P support, on x86_64 Ubuntu 24.04.2 / glibc 2.39 under WSL2. This is validation of the provided static RV64 C example, not certification of the full P ISA or other toolchain configurations. P 0.6 is a developed draft, not ratified. Code and tutorial license: MIT. See VERSION.json, VALIDATION.md and licenses/NOTICE for details.</a:t>
             </a:r>
             <a:endParaRPr b="0" lang="en-US" sz="2000" spc="-1" strike="noStrike">
               <a:solidFill>
@@ -953,7 +953,7 @@
         <p:txBody>
           <a:bodyPr/>
           <a:p>
-            <a:fld id="{24281D6B-A660-4193-951F-C1E871787E9E}" type="slidenum">
+            <a:fld id="{E5EE06A7-8226-462C-B07E-144B4DB1AAB2}" type="slidenum">
               <a:t>&lt;#&gt;</a:t>
             </a:fld>
           </a:p>
@@ -1116,7 +1116,7 @@
         <p:txBody>
           <a:bodyPr/>
           <a:p>
-            <a:fld id="{22375BE6-B2E7-4F88-B75A-FD221CA94384}" type="slidenum">
+            <a:fld id="{E195C119-C6C8-4AE8-ADC9-472156A1B064}" type="slidenum">
               <a:t>&lt;#&gt;</a:t>
             </a:fld>
           </a:p>
@@ -1601,7 +1601,7 @@
             <a:pPr indent="0" algn="r">
               <a:buNone/>
             </a:pPr>
-            <a:fld id="{DDE3BF9C-6C1C-421F-8F9B-A080B99493E5}" type="slidenum">
+            <a:fld id="{A1365D0C-833A-4858-96E8-5C86136126FE}" type="slidenum">
               <a:rPr b="0" lang="en-US" sz="1400" spc="-1" strike="noStrike">
                 <a:solidFill>
                   <a:srgbClr val="000000"/>
@@ -5631,7 +5631,7 @@
                 </a:solidFill>
                 <a:latin typeface="Arial"/>
               </a:rPr>
-              <a:t>RUN AFTER BUILDING THE TOOLS</a:t>
+              <a:t>RUN WITH THE INCLUDED TOOLS</a:t>
             </a:r>
             <a:endParaRPr b="0" lang="en-US" sz="1200" spc="-1" strike="noStrike">
               <a:solidFill>

</xml_diff>